<commit_message>
Actualizar Dame tus ojos
</commit_message>
<xml_diff>
--- a/assets/presentations/2026-06-14-dame-tus-ojos.pptx
+++ b/assets/presentations/2026-06-14-dame-tus-ojos.pptx
@@ -2,15 +2,15 @@
 <file path=ppt/presentation.xml><?xml version="1.0" encoding="utf-8"?>
 <p:presentation xmlns:p="http://schemas.openxmlformats.org/presentationml/2006/main">
   <p:sldMasterIdLst>
-    <p:sldMasterId xmlns:r="http://schemas.openxmlformats.org/officeDocument/2006/relationships" id="2147483648" r:id="R9d5e58c8708c43b6"/>
+    <p:sldMasterId xmlns:r="http://schemas.openxmlformats.org/officeDocument/2006/relationships" id="2147483648" r:id="R50cb4c0134fb4792"/>
   </p:sldMasterIdLst>
   <p:notesMasterIdLst>
-    <p:notesMasterId xmlns:r="http://schemas.openxmlformats.org/officeDocument/2006/relationships" r:id="Rf90555672315431e"/>
+    <p:notesMasterId xmlns:r="http://schemas.openxmlformats.org/officeDocument/2006/relationships" r:id="Rc0f419fcfb59422d"/>
   </p:notesMasterIdLst>
   <p:sldIdLst>
-    <p:sldId xmlns:r="http://schemas.openxmlformats.org/officeDocument/2006/relationships" id="256" r:id="Raa0775d0f3694614"/>
-    <p:sldId xmlns:r="http://schemas.openxmlformats.org/officeDocument/2006/relationships" id="257" r:id="R70366e73bc314e1a"/>
-    <p:sldId xmlns:r="http://schemas.openxmlformats.org/officeDocument/2006/relationships" id="258" r:id="Ra51f2f30d863477f"/>
+    <p:sldId xmlns:r="http://schemas.openxmlformats.org/officeDocument/2006/relationships" id="256" r:id="Rf126f7c1178c4746"/>
+    <p:sldId xmlns:r="http://schemas.openxmlformats.org/officeDocument/2006/relationships" id="257" r:id="R5cc5d27d446f493f"/>
+    <p:sldId xmlns:r="http://schemas.openxmlformats.org/officeDocument/2006/relationships" id="258" r:id="R24f27139f0794b28"/>
   </p:sldIdLst>
   <p:sldSz cx="12192000" cy="6858000"/>
   <p:notesSz cx="6858000" cy="9144000"/>
@@ -747,7 +747,7 @@
   </p:cSld>
   <p:clrMap bg1="lt1" tx1="dk1" bg2="lt2" tx2="dk2" accent1="accent1" accent2="accent2" accent3="accent3" accent4="accent4" accent5="accent5" accent6="accent6" hlink="hlink" folHlink="folHlink"/>
   <p:sldLayoutIdLst>
-    <p:sldLayoutId xmlns:r="http://schemas.openxmlformats.org/officeDocument/2006/relationships" id="2147483649" r:id="Rff5403a5b451484d"/>
+    <p:sldLayoutId xmlns:r="http://schemas.openxmlformats.org/officeDocument/2006/relationships" id="2147483649" r:id="R68ff2087372b467f"/>
   </p:sldLayoutIdLst>
   <p:txStyles>
     <p:titleStyle>
@@ -1295,14 +1295,14 @@
           <p:nvPr/>
         </p:nvPicPr>
         <p:blipFill>
-          <a:blip xmlns:r="http://schemas.openxmlformats.org/officeDocument/2006/relationships" xmlns:a="http://schemas.openxmlformats.org/drawingml/2006/main" r:embed="R960f483d4a0b4b39"/>
+          <a:blip xmlns:r="http://schemas.openxmlformats.org/officeDocument/2006/relationships" xmlns:a="http://schemas.openxmlformats.org/drawingml/2006/main" r:embed="R5fc2b9b2e73147ae"/>
           <a:srcRect xmlns:a="http://schemas.openxmlformats.org/drawingml/2006/main" l="0" t="27" r="0" b="27"/>
           <a:stretch xmlns:a="http://schemas.openxmlformats.org/drawingml/2006/main">
             <a:fillRect l="0" t="0" r="0" b="0"/>
           </a:stretch>
         </p:blipFill>
         <p:spPr>
-          <a:xfrm xmlns:a="http://schemas.openxmlformats.org/drawingml/2006/main">
+          <a:xfrm xmlns:a="http://schemas.openxmlformats.org/drawingml/2006/main" flipH="0" flipV="0">
             <a:off x="0" y="0"/>
             <a:ext cx="12192000" cy="6858000"/>
           </a:xfrm>

</xml_diff>